<commit_message>
Embed grid circles in chart; rounded bars; bold y-labels; no x-axis numbers
- Total circles now rendered inside the matplotlib figure (not PPT overlays).
  Diameter scales with bar height; positioned at each row's top-box %.
- Bars have rounded right corners via quadratic-bezier Path patches.
  Radii are computed to be visually circular (matched in display pixels).
- Grid chart y-axis labels are now bold.
- X-axis tick numbers removed (grid lines kept).
- GRID_AXIS_BOTTOM reduced from 0.12 → 0.05 (no bottom label space needed).
- _text_color_for_bg now returns white on TEAL_MID as well.

https://claude.ai/code/session_01VCXkWfprNAwES9BXV74rqk
</commit_message>
<xml_diff>
--- a/sample_data/output_new.pptx
+++ b/sample_data/output_new.pptx
@@ -9111,22 +9111,181 @@
           </a:prstGeom>
         </p:spPr>
       </p:pic>
-      <p:sp>
-        <p:nvSpPr>
-          <p:cNvPr id="6" name="Oval 5"/>
+      <p:pic>
+        <p:nvPicPr>
+          <p:cNvPr id="6" name="Picture 5" descr="image.png"/>
+          <p:cNvPicPr>
+            <a:picLocks noChangeAspect="1"/>
+          </p:cNvPicPr>
+          <p:nvPr/>
+        </p:nvPicPr>
+        <p:blipFill>
+          <a:blip r:embed="rId3"/>
+          <a:stretch>
+            <a:fillRect/>
+          </a:stretch>
+        </p:blipFill>
+        <p:spPr>
+          <a:xfrm>
+            <a:off x="310896" y="4416552"/>
+            <a:ext cx="6099048" cy="274320"/>
+          </a:xfrm>
+          <a:prstGeom prst="rect">
+            <a:avLst/>
+          </a:prstGeom>
+        </p:spPr>
+      </p:pic>
+      <p:sp>
+        <p:nvSpPr>
+          <p:cNvPr id="7" name="TextBox 6"/>
+          <p:cNvSpPr txBox="1"/>
+          <p:nvPr/>
+        </p:nvSpPr>
+        <p:spPr>
+          <a:xfrm>
+            <a:off x="7068312" y="1463040"/>
+            <a:ext cx="4754879" cy="2880360"/>
+          </a:xfrm>
+          <a:prstGeom prst="rect">
+            <a:avLst/>
+          </a:prstGeom>
+          <a:noFill/>
+        </p:spPr>
+        <p:txBody>
+          <a:bodyPr wrap="square">
+            <a:spAutoFit/>
+          </a:bodyPr>
+          <a:lstStyle/>
+          <a:p>
+            <a:r>
+              <a:rPr sz="1000" b="0">
+                <a:solidFill>
+                  <a:srgbClr val="44546A"/>
+                </a:solidFill>
+                <a:latin typeface="DM Sans"/>
+              </a:rPr>
+              <a:t>Total agree by statement:</a:t>
+            </a:r>
+          </a:p>
+          <a:p>
+            <a:r>
+              <a:rPr sz="1000" b="0">
+                <a:solidFill>
+                  <a:srgbClr val="44546A"/>
+                </a:solidFill>
+                <a:latin typeface="DM Sans"/>
+              </a:rPr>
+              <a:t>– Community impact:   XX%</a:t>
+            </a:r>
+          </a:p>
+          <a:p>
+            <a:r>
+              <a:rPr sz="1000" b="0">
+                <a:solidFill>
+                  <a:srgbClr val="44546A"/>
+                </a:solidFill>
+                <a:latin typeface="DM Sans"/>
+              </a:rPr>
+              <a:t>– Govt leadership:    XX%</a:t>
+            </a:r>
+          </a:p>
+          <a:p>
+            <a:r>
+              <a:rPr sz="1000" b="0">
+                <a:solidFill>
+                  <a:srgbClr val="44546A"/>
+                </a:solidFill>
+                <a:latin typeface="DM Sans"/>
+              </a:rPr>
+              <a:t>– Local action:       XX%</a:t>
+            </a:r>
+          </a:p>
+          <a:p>
+            <a:r>
+              <a:rPr sz="1000" b="0">
+                <a:solidFill>
+                  <a:srgbClr val="44546A"/>
+                </a:solidFill>
+                <a:latin typeface="DM Sans"/>
+              </a:rPr>
+              <a:t/>
+            </a:r>
+          </a:p>
+          <a:p>
+            <a:r>
+              <a:rPr sz="1000" b="0">
+                <a:solidFill>
+                  <a:srgbClr val="44546A"/>
+                </a:solidFill>
+                <a:latin typeface="DM Sans"/>
+              </a:rPr>
+              <a:t>Agreement is broadly consistent</a:t>
+            </a:r>
+          </a:p>
+          <a:p>
+            <a:r>
+              <a:rPr sz="1000" b="0">
+                <a:solidFill>
+                  <a:srgbClr val="44546A"/>
+                </a:solidFill>
+                <a:latin typeface="DM Sans"/>
+              </a:rPr>
+              <a:t>across age groups and regions.</a:t>
+            </a:r>
+          </a:p>
+        </p:txBody>
+      </p:sp>
+      <p:sp>
+        <p:nvSpPr>
+          <p:cNvPr id="8" name="TextBox 7"/>
+          <p:cNvSpPr txBox="1"/>
+          <p:nvPr/>
+        </p:nvSpPr>
+        <p:spPr>
+          <a:xfrm>
+            <a:off x="1097280" y="6236208"/>
+            <a:ext cx="10058400" cy="256032"/>
+          </a:xfrm>
+          <a:prstGeom prst="rect">
+            <a:avLst/>
+          </a:prstGeom>
+          <a:noFill/>
+        </p:spPr>
+        <p:txBody>
+          <a:bodyPr wrap="square">
+            <a:spAutoFit/>
+          </a:bodyPr>
+          <a:lstStyle/>
+          <a:p>
+            <a:pPr algn="l"/>
+            <a:r>
+              <a:rPr sz="800" b="0" i="1">
+                <a:solidFill>
+                  <a:srgbClr val="44546A"/>
+                </a:solidFill>
+                <a:latin typeface="DM Sans"/>
+              </a:rPr>
+              <a:t>Base: all respondents (n=200)</a:t>
+            </a:r>
+          </a:p>
+        </p:txBody>
+      </p:sp>
+      <p:sp>
+        <p:nvSpPr>
+          <p:cNvPr id="9" name="Oval 8"/>
           <p:cNvSpPr/>
           <p:nvPr/>
         </p:nvSpPr>
         <p:spPr>
           <a:xfrm>
-            <a:off x="4505431" y="1686747"/>
-            <a:ext cx="637519" cy="637519"/>
+            <a:off x="11548872" y="6217920"/>
+            <a:ext cx="274320" cy="274320"/>
           </a:xfrm>
           <a:prstGeom prst="ellipse">
             <a:avLst/>
           </a:prstGeom>
           <a:solidFill>
-            <a:srgbClr val="00BDBB"/>
+            <a:srgbClr val="027F7C"/>
           </a:solidFill>
           <a:ln>
             <a:noFill/>
@@ -9156,400 +9315,7 @@
       </p:sp>
       <p:sp>
         <p:nvSpPr>
-          <p:cNvPr id="7" name="TextBox 6"/>
-          <p:cNvSpPr txBox="1"/>
-          <p:nvPr/>
-        </p:nvSpPr>
-        <p:spPr>
-          <a:xfrm>
-            <a:off x="4505431" y="1827002"/>
-            <a:ext cx="637519" cy="357011"/>
-          </a:xfrm>
-          <a:prstGeom prst="rect">
-            <a:avLst/>
-          </a:prstGeom>
-          <a:noFill/>
-        </p:spPr>
-        <p:txBody>
-          <a:bodyPr wrap="square">
-            <a:spAutoFit/>
-          </a:bodyPr>
-          <a:lstStyle/>
-          <a:p>
-            <a:pPr algn="ctr"/>
-            <a:r>
-              <a:rPr sz="1800" b="1" i="0">
-                <a:solidFill>
-                  <a:srgbClr val="FFFFFF"/>
-                </a:solidFill>
-                <a:latin typeface="DM Sans"/>
-              </a:rPr>
-              <a:t>68%</a:t>
-            </a:r>
-          </a:p>
-        </p:txBody>
-      </p:sp>
-      <p:sp>
-        <p:nvSpPr>
-          <p:cNvPr id="8" name="Oval 7"/>
-          <p:cNvSpPr/>
-          <p:nvPr/>
-        </p:nvSpPr>
-        <p:spPr>
-          <a:xfrm>
-            <a:off x="4261469" y="2483647"/>
-            <a:ext cx="637519" cy="637519"/>
-          </a:xfrm>
-          <a:prstGeom prst="ellipse">
-            <a:avLst/>
-          </a:prstGeom>
-          <a:solidFill>
-            <a:srgbClr val="00BDBB"/>
-          </a:solidFill>
-          <a:ln>
-            <a:noFill/>
-          </a:ln>
-        </p:spPr>
-        <p:style>
-          <a:lnRef idx="1">
-            <a:schemeClr val="accent1"/>
-          </a:lnRef>
-          <a:fillRef idx="3">
-            <a:schemeClr val="accent1"/>
-          </a:fillRef>
-          <a:effectRef idx="2">
-            <a:schemeClr val="accent1"/>
-          </a:effectRef>
-          <a:fontRef idx="minor">
-            <a:schemeClr val="lt1"/>
-          </a:fontRef>
-        </p:style>
-        <p:txBody>
-          <a:bodyPr rtlCol="0" anchor="ctr"/>
-          <a:lstStyle/>
-          <a:p>
-            <a:pPr algn="ctr"/>
-          </a:p>
-        </p:txBody>
-      </p:sp>
-      <p:sp>
-        <p:nvSpPr>
-          <p:cNvPr id="9" name="TextBox 8"/>
-          <p:cNvSpPr txBox="1"/>
-          <p:nvPr/>
-        </p:nvSpPr>
-        <p:spPr>
-          <a:xfrm>
-            <a:off x="4261469" y="2623901"/>
-            <a:ext cx="637519" cy="357011"/>
-          </a:xfrm>
-          <a:prstGeom prst="rect">
-            <a:avLst/>
-          </a:prstGeom>
-          <a:noFill/>
-        </p:spPr>
-        <p:txBody>
-          <a:bodyPr wrap="square">
-            <a:spAutoFit/>
-          </a:bodyPr>
-          <a:lstStyle/>
-          <a:p>
-            <a:pPr algn="ctr"/>
-            <a:r>
-              <a:rPr sz="1800" b="1" i="0">
-                <a:solidFill>
-                  <a:srgbClr val="FFFFFF"/>
-                </a:solidFill>
-                <a:latin typeface="DM Sans"/>
-              </a:rPr>
-              <a:t>60%</a:t>
-            </a:r>
-          </a:p>
-        </p:txBody>
-      </p:sp>
-      <p:sp>
-        <p:nvSpPr>
-          <p:cNvPr id="10" name="Oval 9"/>
-          <p:cNvSpPr/>
-          <p:nvPr/>
-        </p:nvSpPr>
-        <p:spPr>
-          <a:xfrm>
-            <a:off x="4566422" y="3280547"/>
-            <a:ext cx="637519" cy="637519"/>
-          </a:xfrm>
-          <a:prstGeom prst="ellipse">
-            <a:avLst/>
-          </a:prstGeom>
-          <a:solidFill>
-            <a:srgbClr val="00BDBB"/>
-          </a:solidFill>
-          <a:ln>
-            <a:noFill/>
-          </a:ln>
-        </p:spPr>
-        <p:style>
-          <a:lnRef idx="1">
-            <a:schemeClr val="accent1"/>
-          </a:lnRef>
-          <a:fillRef idx="3">
-            <a:schemeClr val="accent1"/>
-          </a:fillRef>
-          <a:effectRef idx="2">
-            <a:schemeClr val="accent1"/>
-          </a:effectRef>
-          <a:fontRef idx="minor">
-            <a:schemeClr val="lt1"/>
-          </a:fontRef>
-        </p:style>
-        <p:txBody>
-          <a:bodyPr rtlCol="0" anchor="ctr"/>
-          <a:lstStyle/>
-          <a:p>
-            <a:pPr algn="ctr"/>
-          </a:p>
-        </p:txBody>
-      </p:sp>
-      <p:sp>
-        <p:nvSpPr>
-          <p:cNvPr id="11" name="TextBox 10"/>
-          <p:cNvSpPr txBox="1"/>
-          <p:nvPr/>
-        </p:nvSpPr>
-        <p:spPr>
-          <a:xfrm>
-            <a:off x="4566422" y="3420801"/>
-            <a:ext cx="637519" cy="357011"/>
-          </a:xfrm>
-          <a:prstGeom prst="rect">
-            <a:avLst/>
-          </a:prstGeom>
-          <a:noFill/>
-        </p:spPr>
-        <p:txBody>
-          <a:bodyPr wrap="square">
-            <a:spAutoFit/>
-          </a:bodyPr>
-          <a:lstStyle/>
-          <a:p>
-            <a:pPr algn="ctr"/>
-            <a:r>
-              <a:rPr sz="1800" b="1" i="0">
-                <a:solidFill>
-                  <a:srgbClr val="FFFFFF"/>
-                </a:solidFill>
-                <a:latin typeface="DM Sans"/>
-              </a:rPr>
-              <a:t>70%</a:t>
-            </a:r>
-          </a:p>
-        </p:txBody>
-      </p:sp>
-      <p:pic>
-        <p:nvPicPr>
-          <p:cNvPr id="12" name="Picture 11" descr="image.png"/>
-          <p:cNvPicPr>
-            <a:picLocks noChangeAspect="1"/>
-          </p:cNvPicPr>
-          <p:nvPr/>
-        </p:nvPicPr>
-        <p:blipFill>
-          <a:blip r:embed="rId3"/>
-          <a:stretch>
-            <a:fillRect/>
-          </a:stretch>
-        </p:blipFill>
-        <p:spPr>
-          <a:xfrm>
-            <a:off x="310896" y="4416552"/>
-            <a:ext cx="6099048" cy="274320"/>
-          </a:xfrm>
-          <a:prstGeom prst="rect">
-            <a:avLst/>
-          </a:prstGeom>
-        </p:spPr>
-      </p:pic>
-      <p:sp>
-        <p:nvSpPr>
-          <p:cNvPr id="13" name="TextBox 12"/>
-          <p:cNvSpPr txBox="1"/>
-          <p:nvPr/>
-        </p:nvSpPr>
-        <p:spPr>
-          <a:xfrm>
-            <a:off x="7068312" y="1463040"/>
-            <a:ext cx="4754879" cy="2880360"/>
-          </a:xfrm>
-          <a:prstGeom prst="rect">
-            <a:avLst/>
-          </a:prstGeom>
-          <a:noFill/>
-        </p:spPr>
-        <p:txBody>
-          <a:bodyPr wrap="square">
-            <a:spAutoFit/>
-          </a:bodyPr>
-          <a:lstStyle/>
-          <a:p>
-            <a:r>
-              <a:rPr sz="1000" b="0">
-                <a:solidFill>
-                  <a:srgbClr val="44546A"/>
-                </a:solidFill>
-                <a:latin typeface="DM Sans"/>
-              </a:rPr>
-              <a:t>Total agree by statement:</a:t>
-            </a:r>
-          </a:p>
-          <a:p>
-            <a:r>
-              <a:rPr sz="1000" b="0">
-                <a:solidFill>
-                  <a:srgbClr val="44546A"/>
-                </a:solidFill>
-                <a:latin typeface="DM Sans"/>
-              </a:rPr>
-              <a:t>– Community impact:   XX%</a:t>
-            </a:r>
-          </a:p>
-          <a:p>
-            <a:r>
-              <a:rPr sz="1000" b="0">
-                <a:solidFill>
-                  <a:srgbClr val="44546A"/>
-                </a:solidFill>
-                <a:latin typeface="DM Sans"/>
-              </a:rPr>
-              <a:t>– Govt leadership:    XX%</a:t>
-            </a:r>
-          </a:p>
-          <a:p>
-            <a:r>
-              <a:rPr sz="1000" b="0">
-                <a:solidFill>
-                  <a:srgbClr val="44546A"/>
-                </a:solidFill>
-                <a:latin typeface="DM Sans"/>
-              </a:rPr>
-              <a:t>– Local action:       XX%</a:t>
-            </a:r>
-          </a:p>
-          <a:p>
-            <a:r>
-              <a:rPr sz="1000" b="0">
-                <a:solidFill>
-                  <a:srgbClr val="44546A"/>
-                </a:solidFill>
-                <a:latin typeface="DM Sans"/>
-              </a:rPr>
-              <a:t/>
-            </a:r>
-          </a:p>
-          <a:p>
-            <a:r>
-              <a:rPr sz="1000" b="0">
-                <a:solidFill>
-                  <a:srgbClr val="44546A"/>
-                </a:solidFill>
-                <a:latin typeface="DM Sans"/>
-              </a:rPr>
-              <a:t>Agreement is broadly consistent</a:t>
-            </a:r>
-          </a:p>
-          <a:p>
-            <a:r>
-              <a:rPr sz="1000" b="0">
-                <a:solidFill>
-                  <a:srgbClr val="44546A"/>
-                </a:solidFill>
-                <a:latin typeface="DM Sans"/>
-              </a:rPr>
-              <a:t>across age groups and regions.</a:t>
-            </a:r>
-          </a:p>
-        </p:txBody>
-      </p:sp>
-      <p:sp>
-        <p:nvSpPr>
-          <p:cNvPr id="14" name="TextBox 13"/>
-          <p:cNvSpPr txBox="1"/>
-          <p:nvPr/>
-        </p:nvSpPr>
-        <p:spPr>
-          <a:xfrm>
-            <a:off x="1097280" y="6236208"/>
-            <a:ext cx="10058400" cy="256032"/>
-          </a:xfrm>
-          <a:prstGeom prst="rect">
-            <a:avLst/>
-          </a:prstGeom>
-          <a:noFill/>
-        </p:spPr>
-        <p:txBody>
-          <a:bodyPr wrap="square">
-            <a:spAutoFit/>
-          </a:bodyPr>
-          <a:lstStyle/>
-          <a:p>
-            <a:pPr algn="l"/>
-            <a:r>
-              <a:rPr sz="800" b="0" i="1">
-                <a:solidFill>
-                  <a:srgbClr val="44546A"/>
-                </a:solidFill>
-                <a:latin typeface="DM Sans"/>
-              </a:rPr>
-              <a:t>Base: all respondents (n=200)</a:t>
-            </a:r>
-          </a:p>
-        </p:txBody>
-      </p:sp>
-      <p:sp>
-        <p:nvSpPr>
-          <p:cNvPr id="15" name="Oval 14"/>
-          <p:cNvSpPr/>
-          <p:nvPr/>
-        </p:nvSpPr>
-        <p:spPr>
-          <a:xfrm>
-            <a:off x="11548872" y="6217920"/>
-            <a:ext cx="274320" cy="274320"/>
-          </a:xfrm>
-          <a:prstGeom prst="ellipse">
-            <a:avLst/>
-          </a:prstGeom>
-          <a:solidFill>
-            <a:srgbClr val="027F7C"/>
-          </a:solidFill>
-          <a:ln>
-            <a:noFill/>
-          </a:ln>
-        </p:spPr>
-        <p:style>
-          <a:lnRef idx="1">
-            <a:schemeClr val="accent1"/>
-          </a:lnRef>
-          <a:fillRef idx="3">
-            <a:schemeClr val="accent1"/>
-          </a:fillRef>
-          <a:effectRef idx="2">
-            <a:schemeClr val="accent1"/>
-          </a:effectRef>
-          <a:fontRef idx="minor">
-            <a:schemeClr val="lt1"/>
-          </a:fontRef>
-        </p:style>
-        <p:txBody>
-          <a:bodyPr rtlCol="0" anchor="ctr"/>
-          <a:lstStyle/>
-          <a:p>
-            <a:pPr algn="ctr"/>
-          </a:p>
-        </p:txBody>
-      </p:sp>
-      <p:sp>
-        <p:nvSpPr>
-          <p:cNvPr id="16" name="TextBox 15"/>
+          <p:cNvPr id="10" name="TextBox 9"/>
           <p:cNvSpPr txBox="1"/>
           <p:nvPr/>
         </p:nvSpPr>

</xml_diff>